<commit_message>
feat: certificado em duas paginas com conteudo programatico
</commit_message>
<xml_diff>
--- a/public/certificados/FOR-CCR-006.r03_Modelo_de_Certificado.pptx
+++ b/public/certificados/FOR-CCR-006.r03_Modelo_de_Certificado.pptx
@@ -4,6 +4,9 @@
   <p:sldMasterIdLst>
     <p:sldMasterId id="2147483672" r:id="rId1"/>
   </p:sldMasterIdLst>
+  <p:notesMasterIdLst>
+    <p:notesMasterId r:id="rId4"/>
+  </p:notesMasterIdLst>
   <p:sldIdLst>
     <p:sldId id="256" r:id="rId2"/>
     <p:sldId id="257" r:id="rId3"/>
@@ -137,9 +140,358 @@
 <file path=ppt/revisionInfo.xml><?xml version="1.0" encoding="utf-8"?>
 <p1510:revInfo xmlns:a="http://schemas.openxmlformats.org/drawingml/2006/main" xmlns:r="http://schemas.openxmlformats.org/officeDocument/2006/relationships" xmlns:p1510="http://schemas.microsoft.com/office/powerpoint/2015/10/main">
   <p1510:revLst>
-    <p1510:client id="{93573FF7-12B9-43B8-A737-ED327AAFA95A}" v="9" dt="2026-05-19T20:38:42.199"/>
+    <p1510:client id="{67CD1653-5576-469B-9B33-F3453F4C88ED}" v="1" dt="2026-02-09T17:52:21.590"/>
   </p1510:revLst>
 </p1510:revInfo>
+</file>
+
+<file path=ppt/notesMasters/notesMaster1.xml><?xml version="1.0" encoding="utf-8"?>
+<p:notesMaster xmlns:a="http://schemas.openxmlformats.org/drawingml/2006/main" xmlns:r="http://schemas.openxmlformats.org/officeDocument/2006/relationships" xmlns:p="http://schemas.openxmlformats.org/presentationml/2006/main">
+  <p:cSld>
+    <p:bg>
+      <p:bgRef idx="1001">
+        <a:schemeClr val="bg1"/>
+      </p:bgRef>
+    </p:bg>
+    <p:spTree>
+      <p:nvGrpSpPr>
+        <p:cNvPr id="1" name=""/>
+        <p:cNvGrpSpPr/>
+        <p:nvPr/>
+      </p:nvGrpSpPr>
+      <p:grpSpPr>
+        <a:xfrm>
+          <a:off x="0" y="0"/>
+          <a:ext cx="0" cy="0"/>
+          <a:chOff x="0" y="0"/>
+          <a:chExt cx="0" cy="0"/>
+        </a:xfrm>
+      </p:grpSpPr>
+      <p:sp>
+        <p:nvSpPr>
+          <p:cNvPr id="2" name="Espaço Reservado para Cabeçalho 1"/>
+          <p:cNvSpPr>
+            <a:spLocks noGrp="1"/>
+          </p:cNvSpPr>
+          <p:nvPr>
+            <p:ph type="hdr" sz="quarter"/>
+          </p:nvPr>
+        </p:nvSpPr>
+        <p:spPr>
+          <a:xfrm>
+            <a:off x="0" y="0"/>
+            <a:ext cx="3079202" cy="512304"/>
+          </a:xfrm>
+          <a:prstGeom prst="rect">
+            <a:avLst/>
+          </a:prstGeom>
+        </p:spPr>
+        <p:txBody>
+          <a:bodyPr vert="horz" lIns="94796" tIns="47398" rIns="94796" bIns="47398" rtlCol="0"/>
+          <a:lstStyle>
+            <a:lvl1pPr algn="l">
+              <a:defRPr sz="1200"/>
+            </a:lvl1pPr>
+          </a:lstStyle>
+          <a:p>
+            <a:endParaRPr lang="pt-BR"/>
+          </a:p>
+        </p:txBody>
+      </p:sp>
+      <p:sp>
+        <p:nvSpPr>
+          <p:cNvPr id="3" name="Espaço Reservado para Data 2"/>
+          <p:cNvSpPr>
+            <a:spLocks noGrp="1"/>
+          </p:cNvSpPr>
+          <p:nvPr>
+            <p:ph type="dt" idx="1"/>
+          </p:nvPr>
+        </p:nvSpPr>
+        <p:spPr>
+          <a:xfrm>
+            <a:off x="4023203" y="0"/>
+            <a:ext cx="3079202" cy="512304"/>
+          </a:xfrm>
+          <a:prstGeom prst="rect">
+            <a:avLst/>
+          </a:prstGeom>
+        </p:spPr>
+        <p:txBody>
+          <a:bodyPr vert="horz" lIns="94796" tIns="47398" rIns="94796" bIns="47398" rtlCol="0"/>
+          <a:lstStyle>
+            <a:lvl1pPr algn="r">
+              <a:defRPr sz="1200"/>
+            </a:lvl1pPr>
+          </a:lstStyle>
+          <a:p>
+            <a:fld id="{0C8D68F0-419C-455A-9FBC-29D6EA7CAB30}" type="datetimeFigureOut">
+              <a:rPr lang="pt-BR" smtClean="0"/>
+              <a:t>18/09/2026</a:t>
+            </a:fld>
+            <a:endParaRPr lang="pt-BR"/>
+          </a:p>
+        </p:txBody>
+      </p:sp>
+      <p:sp>
+        <p:nvSpPr>
+          <p:cNvPr id="4" name="Espaço Reservado para Imagem de Slide 3"/>
+          <p:cNvSpPr>
+            <a:spLocks noGrp="1" noRot="1" noChangeAspect="1"/>
+          </p:cNvSpPr>
+          <p:nvPr>
+            <p:ph type="sldImg" idx="2"/>
+          </p:nvPr>
+        </p:nvSpPr>
+        <p:spPr>
+          <a:xfrm>
+            <a:off x="1057275" y="1279525"/>
+            <a:ext cx="4989513" cy="3454400"/>
+          </a:xfrm>
+          <a:prstGeom prst="rect">
+            <a:avLst/>
+          </a:prstGeom>
+          <a:noFill/>
+          <a:ln w="12700">
+            <a:solidFill>
+              <a:prstClr val="black"/>
+            </a:solidFill>
+          </a:ln>
+        </p:spPr>
+        <p:txBody>
+          <a:bodyPr vert="horz" lIns="94796" tIns="47398" rIns="94796" bIns="47398" rtlCol="0" anchor="ctr"/>
+          <a:lstStyle/>
+          <a:p>
+            <a:endParaRPr lang="pt-BR"/>
+          </a:p>
+        </p:txBody>
+      </p:sp>
+      <p:sp>
+        <p:nvSpPr>
+          <p:cNvPr id="5" name="Espaço Reservado para Anotações 4"/>
+          <p:cNvSpPr>
+            <a:spLocks noGrp="1"/>
+          </p:cNvSpPr>
+          <p:nvPr>
+            <p:ph type="body" sz="quarter" idx="3"/>
+          </p:nvPr>
+        </p:nvSpPr>
+        <p:spPr>
+          <a:xfrm>
+            <a:off x="710075" y="4924989"/>
+            <a:ext cx="5683914" cy="4029684"/>
+          </a:xfrm>
+          <a:prstGeom prst="rect">
+            <a:avLst/>
+          </a:prstGeom>
+        </p:spPr>
+        <p:txBody>
+          <a:bodyPr vert="horz" lIns="94796" tIns="47398" rIns="94796" bIns="47398" rtlCol="0"/>
+          <a:lstStyle/>
+          <a:p>
+            <a:pPr lvl="0"/>
+            <a:r>
+              <a:rPr lang="pt-BR"/>
+              <a:t>Clique para editar os estilos de texto Mestres</a:t>
+            </a:r>
+          </a:p>
+          <a:p>
+            <a:pPr lvl="1"/>
+            <a:r>
+              <a:rPr lang="pt-BR"/>
+              <a:t>Segundo nível</a:t>
+            </a:r>
+          </a:p>
+          <a:p>
+            <a:pPr lvl="2"/>
+            <a:r>
+              <a:rPr lang="pt-BR"/>
+              <a:t>Terceiro nível</a:t>
+            </a:r>
+          </a:p>
+          <a:p>
+            <a:pPr lvl="3"/>
+            <a:r>
+              <a:rPr lang="pt-BR"/>
+              <a:t>Quarto nível</a:t>
+            </a:r>
+          </a:p>
+          <a:p>
+            <a:pPr lvl="4"/>
+            <a:r>
+              <a:rPr lang="pt-BR"/>
+              <a:t>Quinto nível</a:t>
+            </a:r>
+          </a:p>
+        </p:txBody>
+      </p:sp>
+      <p:sp>
+        <p:nvSpPr>
+          <p:cNvPr id="6" name="Espaço Reservado para Rodapé 5"/>
+          <p:cNvSpPr>
+            <a:spLocks noGrp="1"/>
+          </p:cNvSpPr>
+          <p:nvPr>
+            <p:ph type="ftr" sz="quarter" idx="4"/>
+          </p:nvPr>
+        </p:nvSpPr>
+        <p:spPr>
+          <a:xfrm>
+            <a:off x="0" y="9722309"/>
+            <a:ext cx="3079202" cy="512304"/>
+          </a:xfrm>
+          <a:prstGeom prst="rect">
+            <a:avLst/>
+          </a:prstGeom>
+        </p:spPr>
+        <p:txBody>
+          <a:bodyPr vert="horz" lIns="94796" tIns="47398" rIns="94796" bIns="47398" rtlCol="0" anchor="b"/>
+          <a:lstStyle>
+            <a:lvl1pPr algn="l">
+              <a:defRPr sz="1200"/>
+            </a:lvl1pPr>
+          </a:lstStyle>
+          <a:p>
+            <a:endParaRPr lang="pt-BR"/>
+          </a:p>
+        </p:txBody>
+      </p:sp>
+      <p:sp>
+        <p:nvSpPr>
+          <p:cNvPr id="7" name="Espaço Reservado para Número de Slide 6"/>
+          <p:cNvSpPr>
+            <a:spLocks noGrp="1"/>
+          </p:cNvSpPr>
+          <p:nvPr>
+            <p:ph type="sldNum" sz="quarter" idx="5"/>
+          </p:nvPr>
+        </p:nvSpPr>
+        <p:spPr>
+          <a:xfrm>
+            <a:off x="4023203" y="9722309"/>
+            <a:ext cx="3079202" cy="512304"/>
+          </a:xfrm>
+          <a:prstGeom prst="rect">
+            <a:avLst/>
+          </a:prstGeom>
+        </p:spPr>
+        <p:txBody>
+          <a:bodyPr vert="horz" lIns="94796" tIns="47398" rIns="94796" bIns="47398" rtlCol="0" anchor="b"/>
+          <a:lstStyle>
+            <a:lvl1pPr algn="r">
+              <a:defRPr sz="1200"/>
+            </a:lvl1pPr>
+          </a:lstStyle>
+          <a:p>
+            <a:fld id="{984FAA97-C030-428C-B352-73BDE7381550}" type="slidenum">
+              <a:rPr lang="pt-BR" smtClean="0"/>
+              <a:t>‹nº›</a:t>
+            </a:fld>
+            <a:endParaRPr lang="pt-BR"/>
+          </a:p>
+        </p:txBody>
+      </p:sp>
+    </p:spTree>
+    <p:extLst>
+      <p:ext uri="{BB962C8B-B14F-4D97-AF65-F5344CB8AC3E}">
+        <p14:creationId xmlns:p14="http://schemas.microsoft.com/office/powerpoint/2010/main" val="1310058331"/>
+      </p:ext>
+    </p:extLst>
+  </p:cSld>
+  <p:clrMap bg1="lt1" tx1="dk1" bg2="lt2" tx2="dk2" accent1="accent1" accent2="accent2" accent3="accent3" accent4="accent4" accent5="accent5" accent6="accent6" hlink="hlink" folHlink="folHlink"/>
+  <p:notesStyle>
+    <a:lvl1pPr marL="0" algn="l" defTabSz="914400" rtl="0" eaLnBrk="1" latinLnBrk="0" hangingPunct="1">
+      <a:defRPr sz="1200" kern="1200">
+        <a:solidFill>
+          <a:schemeClr val="tx1"/>
+        </a:solidFill>
+        <a:latin typeface="+mn-lt"/>
+        <a:ea typeface="+mn-ea"/>
+        <a:cs typeface="+mn-cs"/>
+      </a:defRPr>
+    </a:lvl1pPr>
+    <a:lvl2pPr marL="457200" algn="l" defTabSz="914400" rtl="0" eaLnBrk="1" latinLnBrk="0" hangingPunct="1">
+      <a:defRPr sz="1200" kern="1200">
+        <a:solidFill>
+          <a:schemeClr val="tx1"/>
+        </a:solidFill>
+        <a:latin typeface="+mn-lt"/>
+        <a:ea typeface="+mn-ea"/>
+        <a:cs typeface="+mn-cs"/>
+      </a:defRPr>
+    </a:lvl2pPr>
+    <a:lvl3pPr marL="914400" algn="l" defTabSz="914400" rtl="0" eaLnBrk="1" latinLnBrk="0" hangingPunct="1">
+      <a:defRPr sz="1200" kern="1200">
+        <a:solidFill>
+          <a:schemeClr val="tx1"/>
+        </a:solidFill>
+        <a:latin typeface="+mn-lt"/>
+        <a:ea typeface="+mn-ea"/>
+        <a:cs typeface="+mn-cs"/>
+      </a:defRPr>
+    </a:lvl3pPr>
+    <a:lvl4pPr marL="1371600" algn="l" defTabSz="914400" rtl="0" eaLnBrk="1" latinLnBrk="0" hangingPunct="1">
+      <a:defRPr sz="1200" kern="1200">
+        <a:solidFill>
+          <a:schemeClr val="tx1"/>
+        </a:solidFill>
+        <a:latin typeface="+mn-lt"/>
+        <a:ea typeface="+mn-ea"/>
+        <a:cs typeface="+mn-cs"/>
+      </a:defRPr>
+    </a:lvl4pPr>
+    <a:lvl5pPr marL="1828800" algn="l" defTabSz="914400" rtl="0" eaLnBrk="1" latinLnBrk="0" hangingPunct="1">
+      <a:defRPr sz="1200" kern="1200">
+        <a:solidFill>
+          <a:schemeClr val="tx1"/>
+        </a:solidFill>
+        <a:latin typeface="+mn-lt"/>
+        <a:ea typeface="+mn-ea"/>
+        <a:cs typeface="+mn-cs"/>
+      </a:defRPr>
+    </a:lvl5pPr>
+    <a:lvl6pPr marL="2286000" algn="l" defTabSz="914400" rtl="0" eaLnBrk="1" latinLnBrk="0" hangingPunct="1">
+      <a:defRPr sz="1200" kern="1200">
+        <a:solidFill>
+          <a:schemeClr val="tx1"/>
+        </a:solidFill>
+        <a:latin typeface="+mn-lt"/>
+        <a:ea typeface="+mn-ea"/>
+        <a:cs typeface="+mn-cs"/>
+      </a:defRPr>
+    </a:lvl6pPr>
+    <a:lvl7pPr marL="2743200" algn="l" defTabSz="914400" rtl="0" eaLnBrk="1" latinLnBrk="0" hangingPunct="1">
+      <a:defRPr sz="1200" kern="1200">
+        <a:solidFill>
+          <a:schemeClr val="tx1"/>
+        </a:solidFill>
+        <a:latin typeface="+mn-lt"/>
+        <a:ea typeface="+mn-ea"/>
+        <a:cs typeface="+mn-cs"/>
+      </a:defRPr>
+    </a:lvl7pPr>
+    <a:lvl8pPr marL="3200400" algn="l" defTabSz="914400" rtl="0" eaLnBrk="1" latinLnBrk="0" hangingPunct="1">
+      <a:defRPr sz="1200" kern="1200">
+        <a:solidFill>
+          <a:schemeClr val="tx1"/>
+        </a:solidFill>
+        <a:latin typeface="+mn-lt"/>
+        <a:ea typeface="+mn-ea"/>
+        <a:cs typeface="+mn-cs"/>
+      </a:defRPr>
+    </a:lvl8pPr>
+    <a:lvl9pPr marL="3657600" algn="l" defTabSz="914400" rtl="0" eaLnBrk="1" latinLnBrk="0" hangingPunct="1">
+      <a:defRPr sz="1200" kern="1200">
+        <a:solidFill>
+          <a:schemeClr val="tx1"/>
+        </a:solidFill>
+        <a:latin typeface="+mn-lt"/>
+        <a:ea typeface="+mn-ea"/>
+        <a:cs typeface="+mn-cs"/>
+      </a:defRPr>
+    </a:lvl9pPr>
+  </p:notesStyle>
+</p:notesMaster>
 </file>
 
 <file path=ppt/slideLayouts/slideLayout1.xml><?xml version="1.0" encoding="utf-8"?>
@@ -273,7 +625,7 @@
           <a:p>
             <a:fld id="{849AA1B3-8CAB-4A7A-9664-8DFB99A4C6CD}" type="datetimeFigureOut">
               <a:rPr lang="pt-BR" smtClean="0"/>
-              <a:t>09/06/2026</a:t>
+              <a:t>18/09/2026</a:t>
             </a:fld>
             <a:endParaRPr lang="pt-BR"/>
           </a:p>
@@ -443,7 +795,7 @@
           <a:p>
             <a:fld id="{849AA1B3-8CAB-4A7A-9664-8DFB99A4C6CD}" type="datetimeFigureOut">
               <a:rPr lang="pt-BR" smtClean="0"/>
-              <a:t>09/06/2026</a:t>
+              <a:t>18/09/2026</a:t>
             </a:fld>
             <a:endParaRPr lang="pt-BR"/>
           </a:p>
@@ -623,7 +975,7 @@
           <a:p>
             <a:fld id="{849AA1B3-8CAB-4A7A-9664-8DFB99A4C6CD}" type="datetimeFigureOut">
               <a:rPr lang="pt-BR" smtClean="0"/>
-              <a:t>09/06/2026</a:t>
+              <a:t>18/09/2026</a:t>
             </a:fld>
             <a:endParaRPr lang="pt-BR"/>
           </a:p>
@@ -793,7 +1145,7 @@
           <a:p>
             <a:fld id="{849AA1B3-8CAB-4A7A-9664-8DFB99A4C6CD}" type="datetimeFigureOut">
               <a:rPr lang="pt-BR" smtClean="0"/>
-              <a:t>09/06/2026</a:t>
+              <a:t>18/09/2026</a:t>
             </a:fld>
             <a:endParaRPr lang="pt-BR"/>
           </a:p>
@@ -1039,7 +1391,7 @@
           <a:p>
             <a:fld id="{849AA1B3-8CAB-4A7A-9664-8DFB99A4C6CD}" type="datetimeFigureOut">
               <a:rPr lang="pt-BR" smtClean="0"/>
-              <a:t>09/06/2026</a:t>
+              <a:t>18/09/2026</a:t>
             </a:fld>
             <a:endParaRPr lang="pt-BR"/>
           </a:p>
@@ -1271,7 +1623,7 @@
           <a:p>
             <a:fld id="{849AA1B3-8CAB-4A7A-9664-8DFB99A4C6CD}" type="datetimeFigureOut">
               <a:rPr lang="pt-BR" smtClean="0"/>
-              <a:t>09/06/2026</a:t>
+              <a:t>18/09/2026</a:t>
             </a:fld>
             <a:endParaRPr lang="pt-BR"/>
           </a:p>
@@ -1638,7 +1990,7 @@
           <a:p>
             <a:fld id="{849AA1B3-8CAB-4A7A-9664-8DFB99A4C6CD}" type="datetimeFigureOut">
               <a:rPr lang="pt-BR" smtClean="0"/>
-              <a:t>09/06/2026</a:t>
+              <a:t>18/09/2026</a:t>
             </a:fld>
             <a:endParaRPr lang="pt-BR"/>
           </a:p>
@@ -1756,7 +2108,7 @@
           <a:p>
             <a:fld id="{849AA1B3-8CAB-4A7A-9664-8DFB99A4C6CD}" type="datetimeFigureOut">
               <a:rPr lang="pt-BR" smtClean="0"/>
-              <a:t>09/06/2026</a:t>
+              <a:t>18/09/2026</a:t>
             </a:fld>
             <a:endParaRPr lang="pt-BR"/>
           </a:p>
@@ -1851,7 +2203,7 @@
           <a:p>
             <a:fld id="{849AA1B3-8CAB-4A7A-9664-8DFB99A4C6CD}" type="datetimeFigureOut">
               <a:rPr lang="pt-BR" smtClean="0"/>
-              <a:t>09/06/2026</a:t>
+              <a:t>18/09/2026</a:t>
             </a:fld>
             <a:endParaRPr lang="pt-BR"/>
           </a:p>
@@ -2128,7 +2480,7 @@
           <a:p>
             <a:fld id="{849AA1B3-8CAB-4A7A-9664-8DFB99A4C6CD}" type="datetimeFigureOut">
               <a:rPr lang="pt-BR" smtClean="0"/>
-              <a:t>09/06/2026</a:t>
+              <a:t>18/09/2026</a:t>
             </a:fld>
             <a:endParaRPr lang="pt-BR"/>
           </a:p>
@@ -2385,7 +2737,7 @@
           <a:p>
             <a:fld id="{849AA1B3-8CAB-4A7A-9664-8DFB99A4C6CD}" type="datetimeFigureOut">
               <a:rPr lang="pt-BR" smtClean="0"/>
-              <a:t>09/06/2026</a:t>
+              <a:t>18/09/2026</a:t>
             </a:fld>
             <a:endParaRPr lang="pt-BR"/>
           </a:p>
@@ -2598,7 +2950,7 @@
           <a:p>
             <a:fld id="{849AA1B3-8CAB-4A7A-9664-8DFB99A4C6CD}" type="datetimeFigureOut">
               <a:rPr lang="pt-BR" smtClean="0"/>
-              <a:t>09/06/2026</a:t>
+              <a:t>18/09/2026</a:t>
             </a:fld>
             <a:endParaRPr lang="pt-BR"/>
           </a:p>
@@ -3013,15 +3365,15 @@
       </p:grpSpPr>
       <p:pic>
         <p:nvPicPr>
-          <p:cNvPr id="4" name="Imagem 3">
+          <p:cNvPr id="3" name="Imagem 2" descr="Interface gráfica do usuário, Texto, Aplicativo&#10;&#10;O conteúdo gerado por IA pode estar incorreto.">
             <a:extLst>
               <a:ext uri="{FF2B5EF4-FFF2-40B4-BE49-F238E27FC236}">
-                <a16:creationId xmlns:a16="http://schemas.microsoft.com/office/drawing/2014/main" id="{5B54B8E4-8BF1-8FD1-D22D-036DA92CAA29}"/>
+                <a16:creationId xmlns:a16="http://schemas.microsoft.com/office/drawing/2014/main" id="{BE0F5818-5B51-BC3C-1468-CB87432E2295}"/>
               </a:ext>
             </a:extLst>
           </p:cNvPr>
           <p:cNvPicPr>
-            <a:picLocks noGrp="1" noRot="1" noChangeAspect="1" noMove="1" noResize="1" noEditPoints="1" noAdjustHandles="1" noChangeArrowheads="1" noChangeShapeType="1" noCrop="1"/>
+            <a:picLocks noChangeAspect="1"/>
           </p:cNvPicPr>
           <p:nvPr/>
         </p:nvPicPr>
@@ -3039,14 +3391,240 @@
         </p:blipFill>
         <p:spPr>
           <a:xfrm>
-            <a:off x="0" y="0"/>
-            <a:ext cx="9906000" cy="6858000"/>
+            <a:off x="1" y="0"/>
+            <a:ext cx="9905998" cy="6858000"/>
           </a:xfrm>
           <a:prstGeom prst="rect">
             <a:avLst/>
           </a:prstGeom>
         </p:spPr>
       </p:pic>
+      <p:sp>
+        <p:nvSpPr>
+          <p:cNvPr id="5" name="CaixaDeTexto 4">
+            <a:extLst>
+              <a:ext uri="{FF2B5EF4-FFF2-40B4-BE49-F238E27FC236}">
+                <a16:creationId xmlns:a16="http://schemas.microsoft.com/office/drawing/2014/main" id="{B965AF75-2C0E-5DEA-92EB-6B758D791180}"/>
+              </a:ext>
+            </a:extLst>
+          </p:cNvPr>
+          <p:cNvSpPr txBox="1"/>
+          <p:nvPr/>
+        </p:nvSpPr>
+        <p:spPr>
+          <a:xfrm>
+            <a:off x="515471" y="2089207"/>
+            <a:ext cx="8875058" cy="3015762"/>
+          </a:xfrm>
+          <a:prstGeom prst="rect">
+            <a:avLst/>
+          </a:prstGeom>
+          <a:noFill/>
+        </p:spPr>
+        <p:txBody>
+          <a:bodyPr wrap="square" rtlCol="0" anchor="ctr">
+            <a:spAutoFit/>
+          </a:bodyPr>
+          <a:lstStyle/>
+          <a:p>
+            <a:pPr algn="ctr">
+              <a:lnSpc>
+                <a:spcPct val="150000"/>
+              </a:lnSpc>
+            </a:pPr>
+            <a:r>
+              <a:rPr lang="pt-BR" sz="1200" dirty="0">
+                <a:latin typeface="Montserrat" pitchFamily="2" charset="-18"/>
+              </a:rPr>
+              <a:t>A Edeconsil certifica que</a:t>
+            </a:r>
+          </a:p>
+          <a:p>
+            <a:pPr algn="ctr">
+              <a:lnSpc>
+                <a:spcPct val="150000"/>
+              </a:lnSpc>
+            </a:pPr>
+            <a:r>
+              <a:rPr lang="pt-BR" sz="1200" dirty="0">
+                <a:latin typeface="Montserrat" pitchFamily="2" charset="-18"/>
+              </a:rPr>
+              <a:t>	</a:t>
+            </a:r>
+          </a:p>
+          <a:p>
+            <a:pPr algn="ctr">
+              <a:buNone/>
+            </a:pPr>
+            <a:r>
+              <a:rPr lang="pt-BR" b="1" dirty="0">
+                <a:solidFill>
+                  <a:srgbClr val="000000"/>
+                </a:solidFill>
+                <a:latin typeface="Calibri" panose="020F0502020204030204" pitchFamily="34" charset="0"/>
+                <a:ea typeface="Times New Roman" panose="02020603050405020304" pitchFamily="18" charset="0"/>
+                <a:cs typeface="Times New Roman" panose="02020603050405020304" pitchFamily="18" charset="0"/>
+              </a:rPr>
+              <a:t>CARLOS AUGUSTO PEREIRA LIMA JUNIOR</a:t>
+            </a:r>
+            <a:endParaRPr lang="pt-BR" b="1" dirty="0">
+              <a:latin typeface="Arial" panose="020B0604020202020204" pitchFamily="34" charset="0"/>
+              <a:ea typeface="Times New Roman" panose="02020603050405020304" pitchFamily="18" charset="0"/>
+              <a:cs typeface="Times New Roman" panose="02020603050405020304" pitchFamily="18" charset="0"/>
+            </a:endParaRPr>
+          </a:p>
+          <a:p>
+            <a:pPr algn="ctr">
+              <a:buNone/>
+            </a:pPr>
+            <a:endParaRPr lang="pt-BR" sz="1200" b="1" dirty="0">
+              <a:latin typeface="Montserrat" pitchFamily="2" charset="-18"/>
+            </a:endParaRPr>
+          </a:p>
+          <a:p>
+            <a:pPr algn="ctr">
+              <a:lnSpc>
+                <a:spcPct val="150000"/>
+              </a:lnSpc>
+            </a:pPr>
+            <a:r>
+              <a:rPr lang="pt-BR" sz="1200" dirty="0">
+                <a:latin typeface="Montserrat" pitchFamily="2" charset="-18"/>
+              </a:rPr>
+              <a:t>Concluiu com êxito o treinamento da Norma Regulamentadora </a:t>
+            </a:r>
+            <a:r>
+              <a:rPr lang="pt-BR" sz="1200" b="1" dirty="0">
+                <a:latin typeface="Montserrat" pitchFamily="2" charset="-18"/>
+              </a:rPr>
+              <a:t>capacitação básica em segurança do trabalho</a:t>
+            </a:r>
+            <a:r>
+              <a:rPr lang="pt-BR" sz="1200" dirty="0">
+                <a:latin typeface="Montserrat" pitchFamily="2" charset="-18"/>
+              </a:rPr>
+              <a:t>, com carga horária de 4 horas com validade de </a:t>
+            </a:r>
+            <a:r>
+              <a:rPr lang="pt-BR" sz="1200">
+                <a:latin typeface="Montserrat" pitchFamily="2" charset="-18"/>
+              </a:rPr>
+              <a:t>2 anos, com </a:t>
+            </a:r>
+            <a:r>
+              <a:rPr lang="pt-BR" sz="1200" dirty="0">
+                <a:latin typeface="Montserrat" pitchFamily="2" charset="-18"/>
+              </a:rPr>
+              <a:t>o total de 8 horas de treinamento. realizado em  13 de Agosto de 2026, demonstrando comprometimento e excelência.</a:t>
+            </a:r>
+          </a:p>
+          <a:p>
+            <a:pPr algn="ctr">
+              <a:lnSpc>
+                <a:spcPct val="150000"/>
+              </a:lnSpc>
+            </a:pPr>
+            <a:endParaRPr lang="pt-BR" sz="1200" dirty="0">
+              <a:latin typeface="Montserrat" pitchFamily="2" charset="-18"/>
+            </a:endParaRPr>
+          </a:p>
+          <a:p>
+            <a:pPr algn="just">
+              <a:lnSpc>
+                <a:spcPct val="150000"/>
+              </a:lnSpc>
+            </a:pPr>
+            <a:r>
+              <a:rPr lang="pt-BR" sz="1200" dirty="0">
+                <a:latin typeface="Montserrat" pitchFamily="2" charset="-18"/>
+              </a:rPr>
+              <a:t>Este certificado é concedido como reconhecimento pelo desempenho e dedicação apresentados.</a:t>
+            </a:r>
+          </a:p>
+          <a:p>
+            <a:pPr algn="ctr">
+              <a:lnSpc>
+                <a:spcPct val="150000"/>
+              </a:lnSpc>
+            </a:pPr>
+            <a:r>
+              <a:rPr lang="pt-BR" sz="1200" dirty="0">
+                <a:latin typeface="Montserrat" pitchFamily="2" charset="-18"/>
+              </a:rPr>
+              <a:t>							</a:t>
+            </a:r>
+          </a:p>
+          <a:p>
+            <a:pPr algn="ctr">
+              <a:lnSpc>
+                <a:spcPct val="150000"/>
+              </a:lnSpc>
+            </a:pPr>
+            <a:r>
+              <a:rPr lang="pt-BR" sz="1200" dirty="0">
+                <a:latin typeface="Montserrat" pitchFamily="2" charset="-18"/>
+              </a:rPr>
+              <a:t>São </a:t>
+            </a:r>
+            <a:r>
+              <a:rPr lang="pt-BR" sz="1200" dirty="0" err="1">
+                <a:latin typeface="Montserrat" pitchFamily="2" charset="-18"/>
+              </a:rPr>
+              <a:t>Luís-MA</a:t>
+            </a:r>
+            <a:r>
+              <a:rPr lang="pt-BR" sz="1200" dirty="0">
+                <a:latin typeface="Montserrat" pitchFamily="2" charset="-18"/>
+              </a:rPr>
+              <a:t>, 13 de Agosto de 2026.</a:t>
+            </a:r>
+          </a:p>
+        </p:txBody>
+      </p:sp>
+      <p:sp>
+        <p:nvSpPr>
+          <p:cNvPr id="6" name="CaixaDeTexto 5">
+            <a:extLst>
+              <a:ext uri="{FF2B5EF4-FFF2-40B4-BE49-F238E27FC236}">
+                <a16:creationId xmlns:a16="http://schemas.microsoft.com/office/drawing/2014/main" id="{45621090-F92D-4016-D67D-628D80DBA7BF}"/>
+              </a:ext>
+            </a:extLst>
+          </p:cNvPr>
+          <p:cNvSpPr txBox="1"/>
+          <p:nvPr/>
+        </p:nvSpPr>
+        <p:spPr>
+          <a:xfrm>
+            <a:off x="1985963" y="6272288"/>
+            <a:ext cx="2486025" cy="338554"/>
+          </a:xfrm>
+          <a:prstGeom prst="rect">
+            <a:avLst/>
+          </a:prstGeom>
+          <a:noFill/>
+        </p:spPr>
+        <p:txBody>
+          <a:bodyPr wrap="square" rtlCol="0" anchor="t">
+            <a:spAutoFit/>
+          </a:bodyPr>
+          <a:lstStyle/>
+          <a:p>
+            <a:pPr algn="ctr"/>
+            <a:r>
+              <a:rPr lang="pt-BR" sz="800" dirty="0">
+                <a:latin typeface="Montserrat" pitchFamily="2" charset="-18"/>
+              </a:rPr>
+              <a:t>funcionário</a:t>
+            </a:r>
+          </a:p>
+          <a:p>
+            <a:pPr algn="ctr"/>
+            <a:endParaRPr lang="pt-BR" sz="800" dirty="0">
+              <a:latin typeface="Montserrat" pitchFamily="2" charset="-18"/>
+            </a:endParaRPr>
+          </a:p>
+        </p:txBody>
+      </p:sp>
       <p:sp>
         <p:nvSpPr>
           <p:cNvPr id="7" name="CaixaDeTexto 6">
@@ -3061,8 +3639,8 @@
         </p:nvSpPr>
         <p:spPr>
           <a:xfrm>
-            <a:off x="4037646" y="6272288"/>
-            <a:ext cx="2157414" cy="338554"/>
+            <a:off x="5434012" y="6272288"/>
+            <a:ext cx="2486025" cy="338554"/>
           </a:xfrm>
           <a:prstGeom prst="rect">
             <a:avLst/>
@@ -3080,313 +3658,14 @@
               <a:rPr lang="pt-BR" sz="800" dirty="0">
                 <a:latin typeface="Montserrat" pitchFamily="2" charset="-18"/>
               </a:rPr>
-              <a:t>[Assinatura do responsável]​</a:t>
+              <a:t>Instrutor</a:t>
             </a:r>
           </a:p>
           <a:p>
             <a:pPr algn="ctr"/>
-            <a:r>
-              <a:rPr lang="pt-BR" sz="800" dirty="0">
-                <a:latin typeface="Montserrat" pitchFamily="2" charset="-18"/>
-              </a:rPr>
-              <a:t>[Cargo]</a:t>
-            </a:r>
-          </a:p>
-        </p:txBody>
-      </p:sp>
-      <p:sp>
-        <p:nvSpPr>
-          <p:cNvPr id="2" name="CaixaDeTexto 4">
-            <a:extLst>
-              <a:ext uri="{FF2B5EF4-FFF2-40B4-BE49-F238E27FC236}">
-                <a16:creationId xmlns:a16="http://schemas.microsoft.com/office/drawing/2014/main" id="{B965AF75-2C0E-5DEA-92EB-6B758D791180}"/>
-              </a:ext>
-            </a:extLst>
-          </p:cNvPr>
-          <p:cNvSpPr txBox="1"/>
-          <p:nvPr/>
-        </p:nvSpPr>
-        <p:spPr>
-          <a:xfrm>
-            <a:off x="1676400" y="1828786"/>
-            <a:ext cx="6553200" cy="3200428"/>
-          </a:xfrm>
-          <a:prstGeom prst="rect">
-            <a:avLst/>
-          </a:prstGeom>
-          <a:noFill/>
-        </p:spPr>
-        <p:txBody>
-          <a:bodyPr wrap="square" rtlCol="0" anchor="ctr">
-            <a:spAutoFit/>
-          </a:bodyPr>
-          <a:lstStyle>
-            <a:defPPr>
-              <a:defRPr lang="en-US"/>
-            </a:defPPr>
-            <a:lvl1pPr marL="0" algn="l" defTabSz="457200" rtl="0" eaLnBrk="1" latinLnBrk="0" hangingPunct="1">
-              <a:defRPr sz="1800" kern="1200">
-                <a:solidFill>
-                  <a:schemeClr val="tx1"/>
-                </a:solidFill>
-                <a:latin typeface="+mn-lt"/>
-                <a:ea typeface="+mn-ea"/>
-                <a:cs typeface="+mn-cs"/>
-              </a:defRPr>
-            </a:lvl1pPr>
-            <a:lvl2pPr marL="457200" algn="l" defTabSz="457200" rtl="0" eaLnBrk="1" latinLnBrk="0" hangingPunct="1">
-              <a:defRPr sz="1800" kern="1200">
-                <a:solidFill>
-                  <a:schemeClr val="tx1"/>
-                </a:solidFill>
-                <a:latin typeface="+mn-lt"/>
-                <a:ea typeface="+mn-ea"/>
-                <a:cs typeface="+mn-cs"/>
-              </a:defRPr>
-            </a:lvl2pPr>
-            <a:lvl3pPr marL="914400" algn="l" defTabSz="457200" rtl="0" eaLnBrk="1" latinLnBrk="0" hangingPunct="1">
-              <a:defRPr sz="1800" kern="1200">
-                <a:solidFill>
-                  <a:schemeClr val="tx1"/>
-                </a:solidFill>
-                <a:latin typeface="+mn-lt"/>
-                <a:ea typeface="+mn-ea"/>
-                <a:cs typeface="+mn-cs"/>
-              </a:defRPr>
-            </a:lvl3pPr>
-            <a:lvl4pPr marL="1371600" algn="l" defTabSz="457200" rtl="0" eaLnBrk="1" latinLnBrk="0" hangingPunct="1">
-              <a:defRPr sz="1800" kern="1200">
-                <a:solidFill>
-                  <a:schemeClr val="tx1"/>
-                </a:solidFill>
-                <a:latin typeface="+mn-lt"/>
-                <a:ea typeface="+mn-ea"/>
-                <a:cs typeface="+mn-cs"/>
-              </a:defRPr>
-            </a:lvl4pPr>
-            <a:lvl5pPr marL="1828800" algn="l" defTabSz="457200" rtl="0" eaLnBrk="1" latinLnBrk="0" hangingPunct="1">
-              <a:defRPr sz="1800" kern="1200">
-                <a:solidFill>
-                  <a:schemeClr val="tx1"/>
-                </a:solidFill>
-                <a:latin typeface="+mn-lt"/>
-                <a:ea typeface="+mn-ea"/>
-                <a:cs typeface="+mn-cs"/>
-              </a:defRPr>
-            </a:lvl5pPr>
-            <a:lvl6pPr marL="2286000" algn="l" defTabSz="457200" rtl="0" eaLnBrk="1" latinLnBrk="0" hangingPunct="1">
-              <a:defRPr sz="1800" kern="1200">
-                <a:solidFill>
-                  <a:schemeClr val="tx1"/>
-                </a:solidFill>
-                <a:latin typeface="+mn-lt"/>
-                <a:ea typeface="+mn-ea"/>
-                <a:cs typeface="+mn-cs"/>
-              </a:defRPr>
-            </a:lvl6pPr>
-            <a:lvl7pPr marL="2743200" algn="l" defTabSz="457200" rtl="0" eaLnBrk="1" latinLnBrk="0" hangingPunct="1">
-              <a:defRPr sz="1800" kern="1200">
-                <a:solidFill>
-                  <a:schemeClr val="tx1"/>
-                </a:solidFill>
-                <a:latin typeface="+mn-lt"/>
-                <a:ea typeface="+mn-ea"/>
-                <a:cs typeface="+mn-cs"/>
-              </a:defRPr>
-            </a:lvl7pPr>
-            <a:lvl8pPr marL="3200400" algn="l" defTabSz="457200" rtl="0" eaLnBrk="1" latinLnBrk="0" hangingPunct="1">
-              <a:defRPr sz="1800" kern="1200">
-                <a:solidFill>
-                  <a:schemeClr val="tx1"/>
-                </a:solidFill>
-                <a:latin typeface="+mn-lt"/>
-                <a:ea typeface="+mn-ea"/>
-                <a:cs typeface="+mn-cs"/>
-              </a:defRPr>
-            </a:lvl8pPr>
-            <a:lvl9pPr marL="3657600" algn="l" defTabSz="457200" rtl="0" eaLnBrk="1" latinLnBrk="0" hangingPunct="1">
-              <a:defRPr sz="1800" kern="1200">
-                <a:solidFill>
-                  <a:schemeClr val="tx1"/>
-                </a:solidFill>
-                <a:latin typeface="+mn-lt"/>
-                <a:ea typeface="+mn-ea"/>
-                <a:cs typeface="+mn-cs"/>
-              </a:defRPr>
-            </a:lvl9pPr>
-          </a:lstStyle>
-          <a:p>
-            <a:pPr algn="ctr">
-              <a:lnSpc>
-                <a:spcPct val="150000"/>
-              </a:lnSpc>
-            </a:pPr>
-            <a:r>
-              <a:rPr lang="pt-BR" sz="1200" dirty="0">
-                <a:latin typeface="Montserrat" pitchFamily="2" charset="-18"/>
-              </a:rPr>
-              <a:t>A Edeconsil certifica que</a:t>
-            </a:r>
-          </a:p>
-          <a:p>
-            <a:pPr algn="ctr">
-              <a:lnSpc>
-                <a:spcPct val="150000"/>
-              </a:lnSpc>
-            </a:pPr>
-            <a:endParaRPr lang="pt-BR" sz="1200" dirty="0">
+            <a:endParaRPr lang="pt-BR" sz="800" dirty="0">
               <a:latin typeface="Montserrat" pitchFamily="2" charset="-18"/>
             </a:endParaRPr>
-          </a:p>
-          <a:p>
-            <a:pPr algn="ctr">
-              <a:lnSpc>
-                <a:spcPct val="150000"/>
-              </a:lnSpc>
-            </a:pPr>
-            <a:r>
-              <a:rPr lang="pt-BR" sz="1600" b="1" dirty="0">
-                <a:latin typeface="Montserrat" pitchFamily="2" charset="-18"/>
-              </a:rPr>
-              <a:t>[Nome do Participante]</a:t>
-            </a:r>
-          </a:p>
-          <a:p>
-            <a:pPr algn="ctr">
-              <a:lnSpc>
-                <a:spcPct val="150000"/>
-              </a:lnSpc>
-            </a:pPr>
-            <a:endParaRPr lang="pt-BR" sz="1200" dirty="0">
-              <a:latin typeface="Montserrat" pitchFamily="2" charset="-18"/>
-            </a:endParaRPr>
-          </a:p>
-          <a:p>
-            <a:pPr algn="ctr">
-              <a:lnSpc>
-                <a:spcPct val="150000"/>
-              </a:lnSpc>
-            </a:pPr>
-            <a:r>
-              <a:rPr lang="pt-BR" sz="1200" dirty="0">
-                <a:latin typeface="Montserrat" pitchFamily="2" charset="-18"/>
-              </a:rPr>
-              <a:t>concluiu com êxito [nome do curso, treinamento ou evento], realizado em [data], demonstrando comprometimento e excelência.</a:t>
-            </a:r>
-          </a:p>
-          <a:p>
-            <a:pPr algn="ctr">
-              <a:lnSpc>
-                <a:spcPct val="150000"/>
-              </a:lnSpc>
-            </a:pPr>
-            <a:endParaRPr lang="pt-BR" sz="1200" dirty="0">
-              <a:latin typeface="Montserrat" pitchFamily="2" charset="-18"/>
-            </a:endParaRPr>
-          </a:p>
-          <a:p>
-            <a:pPr algn="ctr">
-              <a:lnSpc>
-                <a:spcPct val="150000"/>
-              </a:lnSpc>
-            </a:pPr>
-            <a:r>
-              <a:rPr lang="pt-BR" sz="1200" dirty="0">
-                <a:latin typeface="Montserrat" pitchFamily="2" charset="-18"/>
-              </a:rPr>
-              <a:t>Este certificado é concedido como reconhecimento pelo desempenho e dedicação apresentados.</a:t>
-            </a:r>
-          </a:p>
-          <a:p>
-            <a:pPr algn="ctr">
-              <a:lnSpc>
-                <a:spcPct val="150000"/>
-              </a:lnSpc>
-            </a:pPr>
-            <a:endParaRPr lang="pt-BR" sz="1200" dirty="0">
-              <a:latin typeface="Montserrat" pitchFamily="2" charset="-18"/>
-            </a:endParaRPr>
-          </a:p>
-          <a:p>
-            <a:pPr algn="ctr">
-              <a:lnSpc>
-                <a:spcPct val="150000"/>
-              </a:lnSpc>
-            </a:pPr>
-            <a:r>
-              <a:rPr lang="pt-BR" sz="1200" dirty="0">
-                <a:latin typeface="Montserrat" pitchFamily="2" charset="-18"/>
-              </a:rPr>
-              <a:t>São Luís, [00] de [Janeiro] de 2026.</a:t>
-            </a:r>
-          </a:p>
-        </p:txBody>
-      </p:sp>
-      <p:sp>
-        <p:nvSpPr>
-          <p:cNvPr id="3" name="CaixaDeTexto 2">
-            <a:extLst>
-              <a:ext uri="{FF2B5EF4-FFF2-40B4-BE49-F238E27FC236}">
-                <a16:creationId xmlns:a16="http://schemas.microsoft.com/office/drawing/2014/main" id="{47CC0341-9CCF-E1C4-F238-F24CCFA02190}"/>
-              </a:ext>
-            </a:extLst>
-          </p:cNvPr>
-          <p:cNvSpPr txBox="1"/>
-          <p:nvPr/>
-        </p:nvSpPr>
-        <p:spPr>
-          <a:xfrm>
-            <a:off x="1150374" y="6072233"/>
-            <a:ext cx="2458065" cy="369332"/>
-          </a:xfrm>
-          <a:prstGeom prst="rect">
-            <a:avLst/>
-          </a:prstGeom>
-          <a:solidFill>
-            <a:schemeClr val="bg1"/>
-          </a:solidFill>
-        </p:spPr>
-        <p:txBody>
-          <a:bodyPr wrap="square" rtlCol="0">
-            <a:spAutoFit/>
-          </a:bodyPr>
-          <a:lstStyle/>
-          <a:p>
-            <a:endParaRPr lang="pt-BR" dirty="0"/>
-          </a:p>
-        </p:txBody>
-      </p:sp>
-      <p:sp>
-        <p:nvSpPr>
-          <p:cNvPr id="5" name="CaixaDeTexto 4">
-            <a:extLst>
-              <a:ext uri="{FF2B5EF4-FFF2-40B4-BE49-F238E27FC236}">
-                <a16:creationId xmlns:a16="http://schemas.microsoft.com/office/drawing/2014/main" id="{5B166CC8-E885-C879-C5BE-85EECD5AEF66}"/>
-              </a:ext>
-            </a:extLst>
-          </p:cNvPr>
-          <p:cNvSpPr txBox="1"/>
-          <p:nvPr/>
-        </p:nvSpPr>
-        <p:spPr>
-          <a:xfrm>
-            <a:off x="6624267" y="6044692"/>
-            <a:ext cx="2458065" cy="369332"/>
-          </a:xfrm>
-          <a:prstGeom prst="rect">
-            <a:avLst/>
-          </a:prstGeom>
-          <a:solidFill>
-            <a:schemeClr val="bg1"/>
-          </a:solidFill>
-        </p:spPr>
-        <p:txBody>
-          <a:bodyPr wrap="square" rtlCol="0">
-            <a:spAutoFit/>
-          </a:bodyPr>
-          <a:lstStyle/>
-          <a:p>
-            <a:endParaRPr lang="pt-BR" dirty="0"/>
           </a:p>
         </p:txBody>
       </p:sp>
@@ -3470,8 +3749,8 @@
         </p:nvSpPr>
         <p:spPr>
           <a:xfrm>
-            <a:off x="428082" y="516401"/>
-            <a:ext cx="8767073" cy="400110"/>
+            <a:off x="369735" y="576908"/>
+            <a:ext cx="8767073" cy="707886"/>
           </a:xfrm>
           <a:prstGeom prst="rect">
             <a:avLst/>
@@ -3485,7 +3764,7 @@
           <a:lstStyle/>
           <a:p>
             <a:r>
-              <a:rPr lang="da-DK" sz="2000" dirty="0">
+              <a:rPr lang="pt-BR" sz="2000" dirty="0">
                 <a:solidFill>
                   <a:srgbClr val="1B54DA"/>
                 </a:solidFill>
@@ -3493,62 +3772,15 @@
                 <a:ea typeface="Roboto Slab" pitchFamily="34" charset="-122"/>
                 <a:cs typeface="Roboto Slab" pitchFamily="34" charset="-120"/>
               </a:rPr>
-              <a:t>Lorem ipsum dolor sit amet.</a:t>
-            </a:r>
+              <a:t>CONTEÚDO PROGRAMÁTICO:</a:t>
+            </a:r>
+          </a:p>
+          <a:p>
             <a:endParaRPr lang="pt-BR" sz="2000" dirty="0">
               <a:solidFill>
                 <a:srgbClr val="1B54DA"/>
               </a:solidFill>
             </a:endParaRPr>
-          </a:p>
-        </p:txBody>
-      </p:sp>
-      <p:sp>
-        <p:nvSpPr>
-          <p:cNvPr id="5" name="CaixaDeTexto 4">
-            <a:extLst>
-              <a:ext uri="{FF2B5EF4-FFF2-40B4-BE49-F238E27FC236}">
-                <a16:creationId xmlns:a16="http://schemas.microsoft.com/office/drawing/2014/main" id="{3FFAC251-0BD1-BF5B-4DEA-48DF922B0E8B}"/>
-              </a:ext>
-            </a:extLst>
-          </p:cNvPr>
-          <p:cNvSpPr txBox="1"/>
-          <p:nvPr/>
-        </p:nvSpPr>
-        <p:spPr>
-          <a:xfrm>
-            <a:off x="543211" y="1068992"/>
-            <a:ext cx="8651944" cy="261610"/>
-          </a:xfrm>
-          <a:prstGeom prst="rect">
-            <a:avLst/>
-          </a:prstGeom>
-          <a:noFill/>
-        </p:spPr>
-        <p:txBody>
-          <a:bodyPr wrap="square">
-            <a:spAutoFit/>
-          </a:bodyPr>
-          <a:lstStyle>
-            <a:defPPr>
-              <a:defRPr lang="en-US"/>
-            </a:defPPr>
-            <a:lvl1pPr marL="342900" indent="-342900">
-              <a:buFont typeface="Wingdings" panose="05000000000000000000" pitchFamily="2" charset="2"/>
-              <a:buChar char="Ø"/>
-              <a:defRPr>
-                <a:latin typeface="Montserrat Black" panose="00000A00000000000000" pitchFamily="2" charset="0"/>
-                <a:ea typeface="Roboto Slab" pitchFamily="34" charset="-122"/>
-                <a:cs typeface="Roboto Slab" pitchFamily="34" charset="-120"/>
-              </a:defRPr>
-            </a:lvl1pPr>
-          </a:lstStyle>
-          <a:p>
-            <a:r>
-              <a:rPr lang="da-DK" sz="1100" dirty="0"/>
-              <a:t>Lorem ipsum dolor sit amet.</a:t>
-            </a:r>
-            <a:endParaRPr lang="pt-BR" sz="1100" dirty="0"/>
           </a:p>
         </p:txBody>
       </p:sp>
@@ -3566,8 +3798,8 @@
         </p:nvSpPr>
         <p:spPr>
           <a:xfrm>
-            <a:off x="597631" y="1330602"/>
-            <a:ext cx="8386509" cy="1628331"/>
+            <a:off x="142164" y="930851"/>
+            <a:ext cx="9621672" cy="5312416"/>
           </a:xfrm>
           <a:prstGeom prst="rect">
             <a:avLst/>
@@ -3594,320 +3826,112 @@
             </a:lvl1pPr>
           </a:lstStyle>
           <a:p>
-            <a:r>
-              <a:rPr lang="pt-BR" sz="1050" dirty="0" err="1"/>
-              <a:t>Lorem</a:t>
-            </a:r>
+            <a:pPr algn="just"/>
+            <a:r>
+              <a:rPr lang="pt-BR" sz="1050" b="1" dirty="0"/>
+              <a:t>CAPACITAÇÃO BÁSICA EM SEGURANÇA DO TRABALHO, SEGURANÇA, SAÚDE E MEIO AMBIENTE – NR 18:</a:t>
+            </a:r>
+          </a:p>
+          <a:p>
+            <a:pPr algn="just"/>
             <a:r>
               <a:rPr lang="pt-BR" sz="1050" dirty="0"/>
-              <a:t> ipsum </a:t>
-            </a:r>
-            <a:r>
-              <a:rPr lang="pt-BR" sz="1050" dirty="0" err="1"/>
-              <a:t>dolor</a:t>
-            </a:r>
+              <a:t>I. as condições e meio ambiente de trabalho; II. os riscos inerentes às atividades desenvolvidas; III. os equipamentos e proteção coletiva existentes no canteiro de obras; IV. o uso adequado dos equipamentos de proteção individual; V. o PGR do canteiro de obras.</a:t>
+            </a:r>
+          </a:p>
+          <a:p>
+            <a:pPr algn="just"/>
             <a:r>
               <a:rPr lang="pt-BR" sz="1050" dirty="0"/>
-              <a:t> </a:t>
-            </a:r>
-            <a:r>
-              <a:rPr lang="pt-BR" sz="1050" dirty="0" err="1"/>
-              <a:t>sit</a:t>
+              <a:t>Uniformes, Equipamentos de Proteção Individual – EPI (Uso, guarda e higienização), Equipamentos de Proteção Coletiva – EPC (Uso, guarda e higienização), proibições, descrições dos riscos da atividade conforme o cargo, medidas de controle, Análise Preliminar de Risco - APR, Programa de Controle Médico de Saúde Ocupacional - PCMSO, Programa de Proteção Respiratória - PPR, Programa de Conservação Auditiva - PCA, Programa de Gerenciamento de Risco - PGR,  Plano de controle Ambiental - PCA, Programa de Gerenciamento de Resíduos Sólidos – PGRS.</a:t>
+            </a:r>
+          </a:p>
+          <a:p>
+            <a:pPr algn="just"/>
+            <a:r>
+              <a:rPr lang="pt-BR" sz="1050" b="1" dirty="0"/>
+              <a:t>PAE - PLANO DE AÇÃO EMERGENCIAL:</a:t>
             </a:r>
             <a:r>
               <a:rPr lang="pt-BR" sz="1050" dirty="0"/>
-              <a:t> </a:t>
-            </a:r>
-            <a:r>
-              <a:rPr lang="pt-BR" sz="1050" dirty="0" err="1"/>
-              <a:t>amet</a:t>
+              <a:t> Introdução, objetivo, aplicação, referências, definições, área de abrangência, caracterização do empreendimento, discrição das situações e procedimentos de emergência, estrutura organizacional de resposta à emergência, fluxograma de acionamento, recursos. Noções de Primeiros Socorros, Noções de combate a Incêndio.</a:t>
+            </a:r>
+          </a:p>
+          <a:p>
+            <a:pPr algn="just"/>
+            <a:r>
+              <a:rPr lang="pt-BR" sz="1050" b="1" dirty="0"/>
+              <a:t>NR 01 – ORDEM DE SERVIÇO: </a:t>
             </a:r>
             <a:r>
               <a:rPr lang="pt-BR" sz="1050" dirty="0"/>
-              <a:t>.</a:t>
-            </a:r>
-          </a:p>
-          <a:p>
-            <a:r>
-              <a:rPr lang="pt-BR" sz="1050" dirty="0" err="1"/>
-              <a:t>Ullamcorper</a:t>
+              <a:t>Atividades de Riscos; os riscos profissionais que possam originar-se nos locais de trabalho; os meios para prevenir e limitar tais riscos e as medidas adotadas pela empresa -EPI e EPC; os resultados das avaliações ambientais realizadas nos locais de trabalho. </a:t>
+            </a:r>
+            <a:r>
+              <a:rPr lang="pt-BR" sz="1050" b="1" dirty="0"/>
+              <a:t>PROGRAMA DE GERENCIAMENTO DE RISCOS (PGR): </a:t>
             </a:r>
             <a:r>
               <a:rPr lang="pt-BR" sz="1050" dirty="0"/>
-              <a:t> </a:t>
-            </a:r>
-            <a:r>
-              <a:rPr lang="pt-BR" sz="1050" dirty="0" err="1"/>
-              <a:t>aliquyam</a:t>
+              <a:t>Postos de Trabalho Descrição dos Ambientes de Trabalho Tipo de Atividade Tarefas a ser executada Grupos Homogêneos de Exposição Caracterização da Exposição a) antecipação e reconhecimentos dos riscos; b) estabelecimento de prioridades e metas de avaliação. </a:t>
+            </a:r>
+          </a:p>
+          <a:p>
+            <a:pPr algn="just"/>
+            <a:r>
+              <a:rPr lang="pt-BR" sz="1050" b="1" dirty="0"/>
+              <a:t>NR 06 - EQUIPAMENTO DE PROTEÇÃO INDIVIDUAL: </a:t>
             </a:r>
             <a:r>
               <a:rPr lang="pt-BR" sz="1050" dirty="0"/>
-              <a:t> exerci.</a:t>
-            </a:r>
-          </a:p>
-          <a:p>
-            <a:r>
-              <a:rPr lang="pt-BR" sz="1050" dirty="0" err="1"/>
-              <a:t>Nonumy</a:t>
+              <a:t>Definição de EPI Responsabilidade quanto ao fornecimento, e uso do EPI Tipos de EPI Aplicação do uso de acordo com a atividade e exposição Uso adequado, guarda e conservação, troca periódica e descarte. Procedimento de requisição e registro de fornecimento.</a:t>
+            </a:r>
+          </a:p>
+          <a:p>
+            <a:pPr algn="just"/>
+            <a:r>
+              <a:rPr lang="pt-BR" sz="1050" b="1" dirty="0"/>
+              <a:t>NR 17 – ERGONOMIA:  </a:t>
             </a:r>
             <a:r>
               <a:rPr lang="pt-BR" sz="1050" dirty="0"/>
-              <a:t> </a:t>
-            </a:r>
-            <a:r>
-              <a:rPr lang="pt-BR" sz="1050" dirty="0" err="1"/>
-              <a:t>dolores</a:t>
-            </a:r>
-            <a:r>
-              <a:rPr lang="pt-BR" sz="1050" dirty="0"/>
-              <a:t> </a:t>
-            </a:r>
-            <a:r>
-              <a:rPr lang="pt-BR" sz="1050" dirty="0" err="1"/>
-              <a:t>sed</a:t>
-            </a:r>
-            <a:r>
-              <a:rPr lang="pt-BR" sz="1050" dirty="0"/>
-              <a:t> </a:t>
-            </a:r>
-            <a:r>
-              <a:rPr lang="pt-BR" sz="1050" dirty="0" err="1"/>
-              <a:t>diam</a:t>
-            </a:r>
-            <a:r>
-              <a:rPr lang="pt-BR" sz="1050" dirty="0"/>
-              <a:t> </a:t>
-            </a:r>
-            <a:r>
-              <a:rPr lang="pt-BR" sz="1050" dirty="0" err="1"/>
-              <a:t>accusam</a:t>
-            </a:r>
-            <a:r>
-              <a:rPr lang="pt-BR" sz="1050" dirty="0"/>
-              <a:t> </a:t>
-            </a:r>
-            <a:r>
-              <a:rPr lang="pt-BR" sz="1050" dirty="0" err="1"/>
-              <a:t>sit</a:t>
-            </a:r>
-            <a:r>
-              <a:rPr lang="pt-BR" sz="1050" dirty="0"/>
-              <a:t> </a:t>
-            </a:r>
-            <a:r>
-              <a:rPr lang="pt-BR" sz="1050" dirty="0" err="1"/>
-              <a:t>nisl</a:t>
-            </a:r>
-            <a:r>
-              <a:rPr lang="pt-BR" sz="1050" dirty="0"/>
-              <a:t> magna. </a:t>
-            </a:r>
-          </a:p>
-          <a:p>
-            <a:r>
-              <a:rPr lang="pt-BR" sz="1050" dirty="0" err="1"/>
-              <a:t>Lobortis</a:t>
-            </a:r>
-            <a:r>
-              <a:rPr lang="pt-BR" sz="1050" dirty="0"/>
-              <a:t> in </a:t>
-            </a:r>
-            <a:r>
-              <a:rPr lang="pt-BR" sz="1050" dirty="0" err="1"/>
-              <a:t>sed</a:t>
-            </a:r>
-            <a:r>
-              <a:rPr lang="pt-BR" sz="1050" dirty="0"/>
-              <a:t>.</a:t>
-            </a:r>
-          </a:p>
-          <a:p>
-            <a:r>
-              <a:rPr lang="pt-BR" sz="1050" dirty="0" err="1"/>
-              <a:t>Diam</a:t>
-            </a:r>
-            <a:r>
-              <a:rPr lang="pt-BR" sz="1050" dirty="0"/>
-              <a:t> vero </a:t>
-            </a:r>
-            <a:r>
-              <a:rPr lang="pt-BR" sz="1050" dirty="0" err="1"/>
-              <a:t>amet</a:t>
-            </a:r>
-            <a:r>
-              <a:rPr lang="pt-BR" sz="1050" dirty="0"/>
-              <a:t> et.</a:t>
-            </a:r>
-          </a:p>
-          <a:p>
-            <a:r>
-              <a:rPr lang="pt-BR" sz="1050" dirty="0" err="1"/>
-              <a:t>Dolor</a:t>
-            </a:r>
-            <a:r>
-              <a:rPr lang="pt-BR" sz="1050" dirty="0"/>
-              <a:t> quis </a:t>
-            </a:r>
-            <a:r>
-              <a:rPr lang="pt-BR" sz="1050" dirty="0" err="1"/>
-              <a:t>eirmod</a:t>
-            </a:r>
-            <a:r>
-              <a:rPr lang="pt-BR" sz="1050" dirty="0"/>
-              <a:t> no </a:t>
-            </a:r>
-            <a:r>
-              <a:rPr lang="pt-BR" sz="1050" dirty="0" err="1"/>
-              <a:t>molestie</a:t>
-            </a:r>
-            <a:r>
-              <a:rPr lang="pt-BR" sz="1050" dirty="0"/>
-              <a:t> </a:t>
-            </a:r>
-            <a:r>
-              <a:rPr lang="pt-BR" sz="1050" dirty="0" err="1"/>
-              <a:t>clita</a:t>
-            </a:r>
-            <a:r>
-              <a:rPr lang="pt-BR" sz="1050" dirty="0"/>
-              <a:t>.</a:t>
-            </a:r>
-          </a:p>
-          <a:p>
-            <a:r>
-              <a:rPr lang="pt-BR" sz="1050" dirty="0"/>
-              <a:t>Ut ipsum et </a:t>
-            </a:r>
-            <a:r>
-              <a:rPr lang="pt-BR" sz="1050" dirty="0" err="1"/>
-              <a:t>diam</a:t>
-            </a:r>
-            <a:r>
-              <a:rPr lang="pt-BR" sz="1050" dirty="0"/>
-              <a:t> et.</a:t>
-            </a:r>
-          </a:p>
-          <a:p>
-            <a:r>
-              <a:rPr lang="pt-BR" sz="1050" dirty="0"/>
-              <a:t>Et </a:t>
-            </a:r>
-            <a:r>
-              <a:rPr lang="pt-BR" sz="1050" dirty="0" err="1"/>
-              <a:t>vel</a:t>
-            </a:r>
-            <a:r>
-              <a:rPr lang="pt-BR" sz="1050" dirty="0"/>
-              <a:t> </a:t>
-            </a:r>
-            <a:r>
-              <a:rPr lang="pt-BR" sz="1050" dirty="0" err="1"/>
-              <a:t>enim</a:t>
-            </a:r>
-            <a:r>
-              <a:rPr lang="pt-BR" sz="1050" dirty="0"/>
-              <a:t> magna </a:t>
-            </a:r>
-            <a:r>
-              <a:rPr lang="pt-BR" sz="1050" dirty="0" err="1"/>
-              <a:t>tempor</a:t>
-            </a:r>
-            <a:r>
-              <a:rPr lang="pt-BR" sz="1050" dirty="0"/>
-              <a:t> no </a:t>
-            </a:r>
-            <a:r>
-              <a:rPr lang="pt-BR" sz="1050" dirty="0" err="1"/>
-              <a:t>nam</a:t>
-            </a:r>
-            <a:r>
-              <a:rPr lang="pt-BR" sz="1050" dirty="0"/>
-              <a:t> ut. </a:t>
-            </a:r>
-          </a:p>
-        </p:txBody>
-      </p:sp>
-      <p:sp>
-        <p:nvSpPr>
-          <p:cNvPr id="7" name="CaixaDeTexto 6">
-            <a:extLst>
-              <a:ext uri="{FF2B5EF4-FFF2-40B4-BE49-F238E27FC236}">
-                <a16:creationId xmlns:a16="http://schemas.microsoft.com/office/drawing/2014/main" id="{041D483D-954B-D824-7B6D-CBED8B484847}"/>
-              </a:ext>
-            </a:extLst>
-          </p:cNvPr>
-          <p:cNvSpPr txBox="1"/>
-          <p:nvPr/>
-        </p:nvSpPr>
-        <p:spPr>
-          <a:xfrm>
-            <a:off x="543211" y="3039392"/>
-            <a:ext cx="8651944" cy="1615827"/>
-          </a:xfrm>
-          <a:prstGeom prst="rect">
-            <a:avLst/>
-          </a:prstGeom>
-          <a:noFill/>
-        </p:spPr>
-        <p:txBody>
-          <a:bodyPr wrap="square">
-            <a:spAutoFit/>
-          </a:bodyPr>
-          <a:lstStyle>
-            <a:defPPr>
-              <a:defRPr lang="en-US"/>
-            </a:defPPr>
-            <a:lvl1pPr marL="342900" indent="-342900">
-              <a:buFont typeface="Wingdings" panose="05000000000000000000" pitchFamily="2" charset="2"/>
-              <a:buChar char="Ø"/>
-              <a:defRPr>
-                <a:latin typeface="Montserrat Black" panose="00000A00000000000000" pitchFamily="2" charset="0"/>
-                <a:ea typeface="Roboto Slab" pitchFamily="34" charset="-122"/>
-                <a:cs typeface="Roboto Slab" pitchFamily="34" charset="-120"/>
-              </a:defRPr>
-            </a:lvl1pPr>
-          </a:lstStyle>
-          <a:p>
-            <a:r>
-              <a:rPr lang="da-DK" sz="1100" dirty="0"/>
-              <a:t>Lorem ipsum dolor sit amet.</a:t>
-            </a:r>
-          </a:p>
-          <a:p>
-            <a:endParaRPr lang="da-DK" sz="1100" dirty="0"/>
-          </a:p>
-          <a:p>
-            <a:r>
-              <a:rPr lang="da-DK" sz="1100" dirty="0"/>
-              <a:t>Lorem ipsum dolor sit amet.</a:t>
-            </a:r>
-          </a:p>
-          <a:p>
-            <a:endParaRPr lang="da-DK" sz="1100" dirty="0"/>
-          </a:p>
-          <a:p>
-            <a:r>
-              <a:rPr lang="da-DK" sz="1100" dirty="0"/>
-              <a:t>Lorem ipsum dolor sit amet.</a:t>
-            </a:r>
-          </a:p>
-          <a:p>
-            <a:endParaRPr lang="da-DK" sz="1100" dirty="0"/>
-          </a:p>
-          <a:p>
-            <a:r>
-              <a:rPr lang="da-DK" sz="1100" dirty="0"/>
-              <a:t>Lorem ipsum dolor sit amet.</a:t>
-            </a:r>
-          </a:p>
-          <a:p>
-            <a:endParaRPr lang="pt-BR" sz="1100" dirty="0"/>
-          </a:p>
-          <a:p>
-            <a:r>
-              <a:rPr lang="da-DK" sz="1100" dirty="0"/>
-              <a:t>Lorem ipsum dolor sit amet.</a:t>
-            </a:r>
+              <a:t>Operacional e administrativa.</a:t>
+            </a:r>
+          </a:p>
+          <a:p>
+            <a:pPr algn="just"/>
+            <a:r>
+              <a:rPr lang="pt-BR" sz="1050" b="1" dirty="0"/>
+              <a:t>PROCEDIMENTO EM SST: </a:t>
+            </a:r>
+            <a:r>
+              <a:rPr lang="pt-PT" sz="1050" dirty="0"/>
+              <a:t>Sistema Qualiex - Gestão da qualidade, documentos, indicadores, não conformidades, avaliação de fornecedores; PGI-CST-001- Gestão de segurança do trabalho; PGI-CST-002- </a:t>
+            </a:r>
+            <a:r>
+              <a:rPr lang="pt-PT" sz="1050" dirty="0" err="1"/>
+              <a:t>Checklist</a:t>
+            </a:r>
+            <a:r>
+              <a:rPr lang="pt-PT" sz="1050" dirty="0"/>
+              <a:t> diário veículos, máquinas e equipamentos; PGI-CST-003- </a:t>
+            </a:r>
+            <a:r>
+              <a:rPr lang="pt-PT" sz="1050" dirty="0" err="1"/>
+              <a:t>Etiquetamento</a:t>
+            </a:r>
+            <a:r>
+              <a:rPr lang="pt-PT" sz="1050" dirty="0"/>
+              <a:t> e Bloqueio; PGI-CST-004- Gestão de equipamento de proteção individual- EPI; PGI-CST-005- Diálogo de saúde e segurança – DSS; PGI-CST-006- Comunicação, análise e investigação de acidentes e incidentes; PGI-CST-007- Análise de riscos de segurança do trabalho; PGI-CST-010- Controle e Prevenção de Álcool e Drogas.</a:t>
+            </a:r>
+          </a:p>
+          <a:p>
+            <a:pPr algn="just"/>
+            <a:endParaRPr lang="pt-BR" sz="1050" dirty="0"/>
+          </a:p>
+          <a:p>
+            <a:pPr algn="just"/>
+            <a:endParaRPr lang="pt-BR" sz="1050" dirty="0"/>
           </a:p>
         </p:txBody>
       </p:sp>
@@ -4237,4 +4261,319 @@
     </a:ext>
   </a:extLst>
 </a:theme>
+</file>
+
+<file path=ppt/theme/theme2.xml><?xml version="1.0" encoding="utf-8"?>
+<a:theme xmlns:a="http://schemas.openxmlformats.org/drawingml/2006/main" name="Tema do Office">
+  <a:themeElements>
+    <a:clrScheme name="Office">
+      <a:dk1>
+        <a:sysClr val="windowText" lastClr="000000"/>
+      </a:dk1>
+      <a:lt1>
+        <a:sysClr val="window" lastClr="FFFFFF"/>
+      </a:lt1>
+      <a:dk2>
+        <a:srgbClr val="0E2841"/>
+      </a:dk2>
+      <a:lt2>
+        <a:srgbClr val="E8E8E8"/>
+      </a:lt2>
+      <a:accent1>
+        <a:srgbClr val="156082"/>
+      </a:accent1>
+      <a:accent2>
+        <a:srgbClr val="E97132"/>
+      </a:accent2>
+      <a:accent3>
+        <a:srgbClr val="196B24"/>
+      </a:accent3>
+      <a:accent4>
+        <a:srgbClr val="0F9ED5"/>
+      </a:accent4>
+      <a:accent5>
+        <a:srgbClr val="A02B93"/>
+      </a:accent5>
+      <a:accent6>
+        <a:srgbClr val="4EA72E"/>
+      </a:accent6>
+      <a:hlink>
+        <a:srgbClr val="467886"/>
+      </a:hlink>
+      <a:folHlink>
+        <a:srgbClr val="96607D"/>
+      </a:folHlink>
+    </a:clrScheme>
+    <a:fontScheme name="Office">
+      <a:majorFont>
+        <a:latin typeface="Aptos Display" panose="02110004020202020204"/>
+        <a:ea typeface=""/>
+        <a:cs typeface=""/>
+        <a:font script="Jpan" typeface="游ゴシック Light"/>
+        <a:font script="Hang" typeface="맑은 고딕"/>
+        <a:font script="Hans" typeface="等线 Light"/>
+        <a:font script="Hant" typeface="新細明體"/>
+        <a:font script="Arab" typeface="Times New Roman"/>
+        <a:font script="Hebr" typeface="Times New Roman"/>
+        <a:font script="Thai" typeface="Angsana New"/>
+        <a:font script="Ethi" typeface="Nyala"/>
+        <a:font script="Beng" typeface="Vrinda"/>
+        <a:font script="Gujr" typeface="Shruti"/>
+        <a:font script="Khmr" typeface="MoolBoran"/>
+        <a:font script="Knda" typeface="Tunga"/>
+        <a:font script="Guru" typeface="Raavi"/>
+        <a:font script="Cans" typeface="Euphemia"/>
+        <a:font script="Cher" typeface="Plantagenet Cherokee"/>
+        <a:font script="Yiii" typeface="Microsoft Yi Baiti"/>
+        <a:font script="Tibt" typeface="Microsoft Himalaya"/>
+        <a:font script="Thaa" typeface="MV Boli"/>
+        <a:font script="Deva" typeface="Mangal"/>
+        <a:font script="Telu" typeface="Gautami"/>
+        <a:font script="Taml" typeface="Latha"/>
+        <a:font script="Syrc" typeface="Estrangelo Edessa"/>
+        <a:font script="Orya" typeface="Kalinga"/>
+        <a:font script="Mlym" typeface="Kartika"/>
+        <a:font script="Laoo" typeface="DokChampa"/>
+        <a:font script="Sinh" typeface="Iskoola Pota"/>
+        <a:font script="Mong" typeface="Mongolian Baiti"/>
+        <a:font script="Viet" typeface="Times New Roman"/>
+        <a:font script="Uigh" typeface="Microsoft Uighur"/>
+        <a:font script="Geor" typeface="Sylfaen"/>
+        <a:font script="Armn" typeface="Arial"/>
+        <a:font script="Bugi" typeface="Leelawadee UI"/>
+        <a:font script="Bopo" typeface="Microsoft JhengHei"/>
+        <a:font script="Java" typeface="Javanese Text"/>
+        <a:font script="Lisu" typeface="Segoe UI"/>
+        <a:font script="Mymr" typeface="Myanmar Text"/>
+        <a:font script="Nkoo" typeface="Ebrima"/>
+        <a:font script="Olck" typeface="Nirmala UI"/>
+        <a:font script="Osma" typeface="Ebrima"/>
+        <a:font script="Phag" typeface="Phagspa"/>
+        <a:font script="Syrn" typeface="Estrangelo Edessa"/>
+        <a:font script="Syrj" typeface="Estrangelo Edessa"/>
+        <a:font script="Syre" typeface="Estrangelo Edessa"/>
+        <a:font script="Sora" typeface="Nirmala UI"/>
+        <a:font script="Tale" typeface="Microsoft Tai Le"/>
+        <a:font script="Talu" typeface="Microsoft New Tai Lue"/>
+        <a:font script="Tfng" typeface="Ebrima"/>
+      </a:majorFont>
+      <a:minorFont>
+        <a:latin typeface="Aptos" panose="02110004020202020204"/>
+        <a:ea typeface=""/>
+        <a:cs typeface=""/>
+        <a:font script="Jpan" typeface="游ゴシック"/>
+        <a:font script="Hang" typeface="맑은 고딕"/>
+        <a:font script="Hans" typeface="等线"/>
+        <a:font script="Hant" typeface="新細明體"/>
+        <a:font script="Arab" typeface="Arial"/>
+        <a:font script="Hebr" typeface="Arial"/>
+        <a:font script="Thai" typeface="Cordia New"/>
+        <a:font script="Ethi" typeface="Nyala"/>
+        <a:font script="Beng" typeface="Vrinda"/>
+        <a:font script="Gujr" typeface="Shruti"/>
+        <a:font script="Khmr" typeface="DaunPenh"/>
+        <a:font script="Knda" typeface="Tunga"/>
+        <a:font script="Guru" typeface="Raavi"/>
+        <a:font script="Cans" typeface="Euphemia"/>
+        <a:font script="Cher" typeface="Plantagenet Cherokee"/>
+        <a:font script="Yiii" typeface="Microsoft Yi Baiti"/>
+        <a:font script="Tibt" typeface="Microsoft Himalaya"/>
+        <a:font script="Thaa" typeface="MV Boli"/>
+        <a:font script="Deva" typeface="Mangal"/>
+        <a:font script="Telu" typeface="Gautami"/>
+        <a:font script="Taml" typeface="Latha"/>
+        <a:font script="Syrc" typeface="Estrangelo Edessa"/>
+        <a:font script="Orya" typeface="Kalinga"/>
+        <a:font script="Mlym" typeface="Kartika"/>
+        <a:font script="Laoo" typeface="DokChampa"/>
+        <a:font script="Sinh" typeface="Iskoola Pota"/>
+        <a:font script="Mong" typeface="Mongolian Baiti"/>
+        <a:font script="Viet" typeface="Arial"/>
+        <a:font script="Uigh" typeface="Microsoft Uighur"/>
+        <a:font script="Geor" typeface="Sylfaen"/>
+        <a:font script="Armn" typeface="Arial"/>
+        <a:font script="Bugi" typeface="Leelawadee UI"/>
+        <a:font script="Bopo" typeface="Microsoft JhengHei"/>
+        <a:font script="Java" typeface="Javanese Text"/>
+        <a:font script="Lisu" typeface="Segoe UI"/>
+        <a:font script="Mymr" typeface="Myanmar Text"/>
+        <a:font script="Nkoo" typeface="Ebrima"/>
+        <a:font script="Olck" typeface="Nirmala UI"/>
+        <a:font script="Osma" typeface="Ebrima"/>
+        <a:font script="Phag" typeface="Phagspa"/>
+        <a:font script="Syrn" typeface="Estrangelo Edessa"/>
+        <a:font script="Syrj" typeface="Estrangelo Edessa"/>
+        <a:font script="Syre" typeface="Estrangelo Edessa"/>
+        <a:font script="Sora" typeface="Nirmala UI"/>
+        <a:font script="Tale" typeface="Microsoft Tai Le"/>
+        <a:font script="Talu" typeface="Microsoft New Tai Lue"/>
+        <a:font script="Tfng" typeface="Ebrima"/>
+      </a:minorFont>
+    </a:fontScheme>
+    <a:fmtScheme name="Office">
+      <a:fillStyleLst>
+        <a:solidFill>
+          <a:schemeClr val="phClr"/>
+        </a:solidFill>
+        <a:gradFill rotWithShape="1">
+          <a:gsLst>
+            <a:gs pos="0">
+              <a:schemeClr val="phClr">
+                <a:lumMod val="110000"/>
+                <a:satMod val="105000"/>
+                <a:tint val="67000"/>
+              </a:schemeClr>
+            </a:gs>
+            <a:gs pos="50000">
+              <a:schemeClr val="phClr">
+                <a:lumMod val="105000"/>
+                <a:satMod val="103000"/>
+                <a:tint val="73000"/>
+              </a:schemeClr>
+            </a:gs>
+            <a:gs pos="100000">
+              <a:schemeClr val="phClr">
+                <a:lumMod val="105000"/>
+                <a:satMod val="109000"/>
+                <a:tint val="81000"/>
+              </a:schemeClr>
+            </a:gs>
+          </a:gsLst>
+          <a:lin ang="5400000" scaled="0"/>
+        </a:gradFill>
+        <a:gradFill rotWithShape="1">
+          <a:gsLst>
+            <a:gs pos="0">
+              <a:schemeClr val="phClr">
+                <a:satMod val="103000"/>
+                <a:lumMod val="102000"/>
+                <a:tint val="94000"/>
+              </a:schemeClr>
+            </a:gs>
+            <a:gs pos="50000">
+              <a:schemeClr val="phClr">
+                <a:satMod val="110000"/>
+                <a:lumMod val="100000"/>
+                <a:shade val="100000"/>
+              </a:schemeClr>
+            </a:gs>
+            <a:gs pos="100000">
+              <a:schemeClr val="phClr">
+                <a:lumMod val="99000"/>
+                <a:satMod val="120000"/>
+                <a:shade val="78000"/>
+              </a:schemeClr>
+            </a:gs>
+          </a:gsLst>
+          <a:lin ang="5400000" scaled="0"/>
+        </a:gradFill>
+      </a:fillStyleLst>
+      <a:lnStyleLst>
+        <a:ln w="12700" cap="flat" cmpd="sng" algn="ctr">
+          <a:solidFill>
+            <a:schemeClr val="phClr"/>
+          </a:solidFill>
+          <a:prstDash val="solid"/>
+          <a:miter lim="800000"/>
+        </a:ln>
+        <a:ln w="19050" cap="flat" cmpd="sng" algn="ctr">
+          <a:solidFill>
+            <a:schemeClr val="phClr"/>
+          </a:solidFill>
+          <a:prstDash val="solid"/>
+          <a:miter lim="800000"/>
+        </a:ln>
+        <a:ln w="25400" cap="flat" cmpd="sng" algn="ctr">
+          <a:solidFill>
+            <a:schemeClr val="phClr"/>
+          </a:solidFill>
+          <a:prstDash val="solid"/>
+          <a:miter lim="800000"/>
+        </a:ln>
+      </a:lnStyleLst>
+      <a:effectStyleLst>
+        <a:effectStyle>
+          <a:effectLst/>
+        </a:effectStyle>
+        <a:effectStyle>
+          <a:effectLst/>
+        </a:effectStyle>
+        <a:effectStyle>
+          <a:effectLst>
+            <a:outerShdw blurRad="57150" dist="19050" dir="5400000" algn="ctr" rotWithShape="0">
+              <a:srgbClr val="000000">
+                <a:alpha val="63000"/>
+              </a:srgbClr>
+            </a:outerShdw>
+          </a:effectLst>
+        </a:effectStyle>
+      </a:effectStyleLst>
+      <a:bgFillStyleLst>
+        <a:solidFill>
+          <a:schemeClr val="phClr"/>
+        </a:solidFill>
+        <a:solidFill>
+          <a:schemeClr val="phClr">
+            <a:tint val="95000"/>
+            <a:satMod val="170000"/>
+          </a:schemeClr>
+        </a:solidFill>
+        <a:gradFill rotWithShape="1">
+          <a:gsLst>
+            <a:gs pos="0">
+              <a:schemeClr val="phClr">
+                <a:tint val="93000"/>
+                <a:satMod val="150000"/>
+                <a:shade val="98000"/>
+                <a:lumMod val="102000"/>
+              </a:schemeClr>
+            </a:gs>
+            <a:gs pos="50000">
+              <a:schemeClr val="phClr">
+                <a:tint val="98000"/>
+                <a:satMod val="130000"/>
+                <a:shade val="90000"/>
+                <a:lumMod val="103000"/>
+              </a:schemeClr>
+            </a:gs>
+            <a:gs pos="100000">
+              <a:schemeClr val="phClr">
+                <a:shade val="63000"/>
+                <a:satMod val="120000"/>
+              </a:schemeClr>
+            </a:gs>
+          </a:gsLst>
+          <a:lin ang="5400000" scaled="0"/>
+        </a:gradFill>
+      </a:bgFillStyleLst>
+    </a:fmtScheme>
+  </a:themeElements>
+  <a:objectDefaults>
+    <a:lnDef>
+      <a:spPr/>
+      <a:bodyPr/>
+      <a:lstStyle/>
+      <a:style>
+        <a:lnRef idx="2">
+          <a:schemeClr val="accent1"/>
+        </a:lnRef>
+        <a:fillRef idx="0">
+          <a:schemeClr val="accent1"/>
+        </a:fillRef>
+        <a:effectRef idx="1">
+          <a:schemeClr val="accent1"/>
+        </a:effectRef>
+        <a:fontRef idx="minor">
+          <a:schemeClr val="tx1"/>
+        </a:fontRef>
+      </a:style>
+    </a:lnDef>
+  </a:objectDefaults>
+  <a:extraClrSchemeLst/>
+  <a:extLst>
+    <a:ext uri="{05A4C25C-085E-4340-85A3-A5531E510DB2}">
+      <thm15:themeFamily xmlns:thm15="http://schemas.microsoft.com/office/thememl/2012/main" name="Office Theme" id="{2E142A2C-CD16-42D6-873A-C26D2A0506FA}" vid="{1BDDFF52-6CD6-40A5-AB3C-68EB2F1E4D0A}"/>
+    </a:ext>
+  </a:extLst>
+</a:theme>
 </file>
</xml_diff>